<commit_message>
W6-Archivfund ohne Krippe aus dem Plattformtitel: hebelistverbogen statt zeitreisebeendet; Test K8 zählt Plattform- und Epochentitel
- W6-A-01 und Akte W6·2 Auftrag 2: `BLJLF ASPPI VLIUI N` (Ring 3, Pendel UHR) → Zwischentext HESELTBI VBEEONRG →
  *hebelistverbogen*; Folie 2, Lehrerhinweise W6, Spec W6 (§0.1, §2, §12), Prüfwerte, Bibliothekstests (JS und
  Python-Zwilling), e2e Szenario 12 nachgezogen; Akte, Präsentation und Lehrerhinweise W6 neu gebaut samt PDFs
- test/inhalte_loesungsverrat: K8 prüft alle Klartexte (Lab, Boss, Archivfund, Papier) gegen die Wörter aus
  Plattformtitel und Epochentiteln
- FACHLICHE_KORREKTUREN D15 ergänzt

Co-Authored-By: Claude Opus 5.5 <noreply@anthropic.com>
Claude-Session: https://claude.ai/code/session_01JKXVQqFeKVmyQ9jfHw4db3
</commit_message>
<xml_diff>
--- a/materialien/Welt6_Zeitmaschine/1_Praesentation/KR_W6_Praesentation_Zeitmaschine.pptx
+++ b/materialien/Welt6_Zeitmaschine/1_Praesentation/KR_W6_Praesentation_Zeitmaschine.pptx
@@ -140,7 +140,7 @@
   <p:extLst>
     <p:ext uri="{521415D9-36F7-43E2-AB2F-B90AF26B5E84}">
       <p14:sectionLst xmlns:p14="http://schemas.microsoft.com/office/powerpoint/2010/main">
-        <p14:section name="Archivfund" id="{af39e2f4-c561-a25b-f31b-8b0337b15f61}">
+        <p14:section name="Archivfund" id="{8181b899-1a29-00e9-fe2e-38e8fac506b4}">
           <p14:sldIdLst>
             <p14:sldId id="256"/>
             <p14:sldId id="257"/>
@@ -150,7 +150,7 @@
             <p14:sldId id="261"/>
           </p14:sldIdLst>
         </p14:section>
-        <p14:section name="Fallenjagd" id="{f8b98800-e647-6f59-0a09-717f187ee61a}">
+        <p14:section name="Fallenjagd" id="{bb25f812-5aa7-00dc-c634-a60dfe87ba1c}">
           <p14:sldIdLst>
             <p14:sldId id="262"/>
             <p14:sldId id="263"/>
@@ -168,7 +168,7 @@
             <p14:sldId id="275"/>
           </p14:sldIdLst>
         </p14:section>
-        <p14:section name="Eves Chiffre" id="{7745ff7b-2f0f-1b37-e856-0ef3b15a3350}">
+        <p14:section name="Eves Chiffre" id="{cac4edb4-e18c-8472-3905-43358a4b95e9}">
           <p14:sldIdLst>
             <p14:sldId id="276"/>
             <p14:sldId id="277"/>
@@ -177,7 +177,7 @@
             <p14:sldId id="280"/>
           </p14:sldIdLst>
         </p14:section>
-        <p14:section name="Generalprobe" id="{3a70f63b-3d30-b643-6d24-8cf4fb2c6adf}">
+        <p14:section name="Generalprobe" id="{978b88e7-fc32-5348-f721-1dfdb8c7fe1e}">
           <p14:sldIdLst>
             <p14:sldId id="281"/>
             <p14:sldId id="282"/>
@@ -189,7 +189,7 @@
             <p14:sldId id="288"/>
           </p14:sldIdLst>
         </p14:section>
-        <p14:section name="Ausblick" id="{a5dd395d-b4fa-96a0-e1af-210e7c80564a}">
+        <p14:section name="Ausblick" id="{17287100-4f46-a2f8-e7ae-1dbbaa9de65a}">
           <p14:sldIdLst>
             <p14:sldId id="289"/>
           </p14:sldIdLst>
@@ -1566,7 +1566,7 @@
           <a:p>
             <a:r>
               <a:rPr lang="en-US" dirty="0"/>
-              <a:t>2 min. Story vorlesen: „Das Archiv ist still geworden. Das Chronoskop, das dich durch zweieinhalb Jahrtausende Geheimschriften getragen hat, rührt sich nicht mehr: Auf seinem Ziffernring leuchtet nur noch eine einzige Zeile. Eve hat die Zeitmaschine mit einer eigenen Chiffre verriegelt, ihrem ‚Uhrwerk‘.“ Impuls: „Was wisst ihr, was fehlt?“ Erwartet: Verfahren + Schlüssel. Kerckhoffs erinnern: Das Verfahren darf bekannt sein (Eves Beschreibung liegt im Archiv) – geheim ist nur der Schlüssel. Lösung (nicht verraten): zeitreisebeendet, t = 3, Pendelwort UHR.</a:t>
+              <a:t>2 min. Story vorlesen: „Das Archiv ist still geworden. Das Chronoskop, das dich durch zweieinhalb Jahrtausende Geheimschriften getragen hat, rührt sich nicht mehr: Auf seinem Ziffernring leuchtet nur noch eine einzige Zeile. Eve hat die Zeitmaschine mit einer eigenen Chiffre verriegelt, ihrem ‚Uhrwerk‘.“ Impuls: „Was wisst ihr, was fehlt?“ Erwartet: Verfahren + Schlüssel. Kerckhoffs erinnern: Das Verfahren darf bekannt sein (Eves Beschreibung liegt im Archiv) – geheim ist nur der Schlüssel. Lösung (nicht verraten): hebelistverbogen, t = 3, Pendelwort UHR.</a:t>
             </a:r>
             <a:endParaRPr lang="en-US" dirty="0"/>
           </a:p>
@@ -1830,7 +1830,7 @@
           <a:p>
             <a:r>
               <a:rPr lang="en-US" dirty="0"/>
-              <a:t>35 min. Material: Archivwissen 1 der Akte W6·2 (im Abitur-Stil), WK2, WK3, Ring-Schablone im Anhang. Langsame Lernende: Pendelzeile UHRHUHRH… vorgeben. Kontrollwerte: Auftrag 2 → zeitreisebeendet; Auftrag 3 → RAVFZ EKTUU AIXIR H. Häufigste Fehler: Zeichen j auf Feld j zurücklegen statt auf Feld (t · j) mod 8 (P3); Pendel mit doppelten Enden (P4).</a:t>
+              <a:t>35 min. Material: Archivwissen 1 der Akte W6·2 (im Abitur-Stil), WK2, WK3, Ring-Schablone im Anhang. Langsame Lernende: Pendelzeile UHRHUHRH… vorgeben. Kontrollwerte: Auftrag 2 → hebelistverbogen; Auftrag 3 → RAVFZ EKTUU AIXIR H. Häufigste Fehler: Zeichen j auf Feld j zurücklegen statt auf Feld (t · j) mod 8 (P3); Pendel mit doppelten Enden (P4).</a:t>
             </a:r>
             <a:endParaRPr lang="en-US" dirty="0"/>
           </a:p>
@@ -1918,7 +1918,7 @@
           <a:p>
             <a:r>
               <a:rPr lang="en-US" dirty="0"/>
-              <a:t>3 min. Sicherung am Ende von DS 17. Archivfund auflösen: ZTIERSIE EEEBNTED → Ring zurück → zeitreisebeendet. Das Chronoskop ist entriegelt.</a:t>
+              <a:t>3 min. Sicherung am Ende von DS 17. Archivfund auflösen: HESELTBI VBEEONRG → Ring zurück → hebelistverbogen. Das Chronoskop ist entriegelt.</a:t>
             </a:r>
             <a:endParaRPr lang="en-US" dirty="0"/>
           </a:p>
@@ -12360,7 +12360,7 @@
                 <a:ea typeface="Consolas" pitchFamily="34" charset="-122"/>
                 <a:cs typeface="Consolas" pitchFamily="34" charset="-120"/>
               </a:rPr>
-              <a:t>TAZLL ZZLYL VIHAV K</a:t>
+              <a:t>BLJLF ASPPI VLIUI N</a:t>
             </a:r>
             <a:endParaRPr lang="en-US" sz="3000" dirty="0"/>
           </a:p>

</xml_diff>